<commit_message>
Completa expediente EP3 y defensa EP4 con evidencias QA
</commit_message>
<xml_diff>
--- a/02_Presentacion_EP4/Presentacion_EP4_Cuidarte.pptx
+++ b/02_Presentacion_EP4/Presentacion_EP4_Cuidarte.pptx
@@ -17,6 +17,8 @@
     <p:sldId id="265" r:id="rId17"/>
     <p:sldId id="266" r:id="rId18"/>
     <p:sldId id="267" r:id="rId19"/>
+    <p:sldId id="268" r:id="rId20"/>
+    <p:sldId id="269" r:id="rId21"/>
   </p:sldIdLst>
   <p:sldSz cx="12191695" cy="6858000" type="screen4x3"/>
   <p:notesSz cx="6858000" cy="9144000"/>
@@ -772,6 +774,146 @@
 </p:notes>
 </file>
 
+<file path=ppt/notesSlides/notesSlide13.xml><?xml version="1.0" encoding="utf-8"?>
+<p:notes xmlns:a="http://schemas.openxmlformats.org/drawingml/2006/main" xmlns:p="http://schemas.openxmlformats.org/presentationml/2006/main" xmlns:r="http://schemas.openxmlformats.org/officeDocument/2006/relationships">
+  <p:cSld>
+    <p:spTree>
+      <p:nvGrpSpPr>
+        <p:cNvPr id="1" name=""/>
+        <p:cNvGrpSpPr/>
+        <p:nvPr/>
+      </p:nvGrpSpPr>
+      <p:grpSpPr>
+        <a:xfrm>
+          <a:off x="0" y="0"/>
+          <a:ext cx="0" cy="0"/>
+          <a:chOff x="0" y="0"/>
+          <a:chExt cx="0" cy="0"/>
+        </a:xfrm>
+      </p:grpSpPr>
+      <p:sp>
+        <p:nvSpPr>
+          <p:cNvPr id="2" name="Slide Image Placeholder 1"/>
+          <p:cNvSpPr>
+            <a:spLocks noGrp="1"/>
+          </p:cNvSpPr>
+          <p:nvPr>
+            <p:ph type="sldImg" idx="2"/>
+          </p:nvPr>
+        </p:nvSpPr>
+        <p:spPr/>
+      </p:sp>
+      <p:sp>
+        <p:nvSpPr>
+          <p:cNvPr id="3" name="Notes Placeholder 2"/>
+          <p:cNvSpPr>
+            <a:spLocks noGrp="1"/>
+          </p:cNvSpPr>
+          <p:nvPr>
+            <p:ph type="body" idx="3" sz="quarter"/>
+          </p:nvPr>
+        </p:nvSpPr>
+        <p:spPr/>
+        <p:txBody>
+          <a:bodyPr/>
+          <a:lstStyle/>
+          <a:p>
+            <a:r>
+              <a:t>Anexo de apoyo para preguntas; no suma tiempo a las doce diapositivas principales. Fuente: resultados_api.png; consultar acta_capturas.json.</a:t>
+            </a:r>
+          </a:p>
+        </p:txBody>
+      </p:sp>
+      <p:sp>
+        <p:nvSpPr>
+          <p:cNvPr id="4" name="Slide Number Placeholder 3"/>
+          <p:cNvSpPr>
+            <a:spLocks noGrp="1"/>
+          </p:cNvSpPr>
+          <p:nvPr>
+            <p:ph type="sldNum" idx="5" sz="quarter"/>
+          </p:nvPr>
+        </p:nvSpPr>
+        <p:spPr/>
+      </p:sp>
+    </p:spTree>
+  </p:cSld>
+  <p:clrMapOvr>
+    <a:masterClrMapping/>
+  </p:clrMapOvr>
+</p:notes>
+</file>
+
+<file path=ppt/notesSlides/notesSlide14.xml><?xml version="1.0" encoding="utf-8"?>
+<p:notes xmlns:a="http://schemas.openxmlformats.org/drawingml/2006/main" xmlns:p="http://schemas.openxmlformats.org/presentationml/2006/main" xmlns:r="http://schemas.openxmlformats.org/officeDocument/2006/relationships">
+  <p:cSld>
+    <p:spTree>
+      <p:nvGrpSpPr>
+        <p:cNvPr id="1" name=""/>
+        <p:cNvGrpSpPr/>
+        <p:nvPr/>
+      </p:nvGrpSpPr>
+      <p:grpSpPr>
+        <a:xfrm>
+          <a:off x="0" y="0"/>
+          <a:ext cx="0" cy="0"/>
+          <a:chOff x="0" y="0"/>
+          <a:chExt cx="0" cy="0"/>
+        </a:xfrm>
+      </p:grpSpPr>
+      <p:sp>
+        <p:nvSpPr>
+          <p:cNvPr id="2" name="Slide Image Placeholder 1"/>
+          <p:cNvSpPr>
+            <a:spLocks noGrp="1"/>
+          </p:cNvSpPr>
+          <p:nvPr>
+            <p:ph type="sldImg" idx="2"/>
+          </p:nvPr>
+        </p:nvSpPr>
+        <p:spPr/>
+      </p:sp>
+      <p:sp>
+        <p:nvSpPr>
+          <p:cNvPr id="3" name="Notes Placeholder 2"/>
+          <p:cNvSpPr>
+            <a:spLocks noGrp="1"/>
+          </p:cNvSpPr>
+          <p:nvPr>
+            <p:ph type="body" idx="3" sz="quarter"/>
+          </p:nvPr>
+        </p:nvSpPr>
+        <p:spPr/>
+        <p:txBody>
+          <a:bodyPr/>
+          <a:lstStyle/>
+          <a:p>
+            <a:r>
+              <a:t>Anexo de apoyo para preguntas; no suma tiempo a las doce diapositivas principales. Fuente: sonarqube_metricas_exportadas.png; consultar acta_capturas.json.</a:t>
+            </a:r>
+          </a:p>
+        </p:txBody>
+      </p:sp>
+      <p:sp>
+        <p:nvSpPr>
+          <p:cNvPr id="4" name="Slide Number Placeholder 3"/>
+          <p:cNvSpPr>
+            <a:spLocks noGrp="1"/>
+          </p:cNvSpPr>
+          <p:nvPr>
+            <p:ph type="sldNum" idx="5" sz="quarter"/>
+          </p:nvPr>
+        </p:nvSpPr>
+        <p:spPr/>
+      </p:sp>
+    </p:spTree>
+  </p:cSld>
+  <p:clrMapOvr>
+    <a:masterClrMapping/>
+  </p:clrMapOvr>
+</p:notes>
+</file>
+
 <file path=ppt/notesSlides/notesSlide2.xml><?xml version="1.0" encoding="utf-8"?>
 <p:notes xmlns:a="http://schemas.openxmlformats.org/drawingml/2006/main" xmlns:p="http://schemas.openxmlformats.org/presentationml/2006/main" xmlns:r="http://schemas.openxmlformats.org/officeDocument/2006/relationships">
   <p:cSld>
@@ -1355,7 +1497,7 @@
           <a:p/>
           <a:p>
             <a:r>
-              <a:t>Estos son los valores de la exportación real de SonarQube y su Quality Gate. Los bugs apuntan a fiabilidad, los code smells a mantenibilidad y los hotspots requieren revisión contextual. Un hotspot no se declara automáticamente una vulnerabilidad. No generamos un reporte LCOV, por lo que la cobertura no demuestra pruebas instrumentadas. Además contrastamos el texto del encargo: el controlador citado para SQLi no existe y las consultas observadas usan parámetros. Reportamos solo lo que consta en el código y en las evidencias, incluso si el analizador no detecta una falla que sí confirma la API.</a:t>
+              <a:t>SonarQube registró un bug de CSS, setenta y dos code smells y tres hotspots de carga, CORS e identificación de Express. Reportó cero vulnerabilidades, pero eso no elimina los defectos críticos que comprobamos por API. Los hotspots siguen pendientes de revisión. La cobertura es cero porque no importamos LCOV. El gate aparece OK con la lista de condiciones vacía: no equivale a cumplir nuestros criterios. También descartamos como no confirmada la SQLi del controlador inexistente del encargo. Las versiones y la advertencia de compatibilidad de Node quedaron documentadas como limitaciones del análisis.</a:t>
             </a:r>
           </a:p>
         </p:txBody>
@@ -6809,6 +6951,184 @@
 </p:sld>
 </file>
 
+<file path=ppt/slides/slide13.xml><?xml version="1.0" encoding="utf-8"?>
+<p:sld xmlns:a="http://schemas.openxmlformats.org/drawingml/2006/main" xmlns:p="http://schemas.openxmlformats.org/presentationml/2006/main" xmlns:r="http://schemas.openxmlformats.org/officeDocument/2006/relationships">
+  <p:cSld>
+    <p:bg>
+      <p:bgPr>
+        <a:solidFill>
+          <a:srgbClr val="0B1E2D"/>
+        </a:solidFill>
+        <a:effectLst/>
+      </p:bgPr>
+    </p:bg>
+    <p:spTree>
+      <p:nvGrpSpPr>
+        <p:cNvPr id="1" name=""/>
+        <p:cNvGrpSpPr/>
+        <p:nvPr/>
+      </p:nvGrpSpPr>
+      <p:grpSpPr/>
+      <p:sp>
+        <p:nvSpPr>
+          <p:cNvPr id="2" name="TextBox 1"/>
+          <p:cNvSpPr txBox="1"/>
+          <p:nvPr/>
+        </p:nvSpPr>
+        <p:spPr>
+          <a:xfrm>
+            <a:off x="548640" y="228600"/>
+            <a:ext cx="10972800" cy="548640"/>
+          </a:xfrm>
+          <a:prstGeom prst="rect">
+            <a:avLst/>
+          </a:prstGeom>
+          <a:noFill/>
+        </p:spPr>
+        <p:txBody>
+          <a:bodyPr wrap="square" lIns="0" rIns="0">
+            <a:spAutoFit/>
+          </a:bodyPr>
+          <a:lstStyle/>
+          <a:p>
+            <a:pPr>
+              <a:spcAft>
+                <a:spcPts val="1000"/>
+              </a:spcAft>
+              <a:defRPr sz="2600" b="1">
+                <a:solidFill>
+                  <a:srgbClr val="F3F7FA"/>
+                </a:solidFill>
+                <a:latin typeface="Aptos"/>
+              </a:defRPr>
+            </a:pPr>
+            <a:r>
+              <a:t>Evidencia A · Ejecución real de API</a:t>
+            </a:r>
+          </a:p>
+        </p:txBody>
+      </p:sp>
+      <p:pic>
+        <p:nvPicPr>
+          <p:cNvPr id="3" name="Picture 2" descr="resultados_api.png"/>
+          <p:cNvPicPr>
+            <a:picLocks noChangeAspect="1"/>
+          </p:cNvPicPr>
+          <p:nvPr/>
+        </p:nvPicPr>
+        <p:blipFill>
+          <a:blip r:embed="rId2"/>
+          <a:stretch>
+            <a:fillRect/>
+          </a:stretch>
+        </p:blipFill>
+        <p:spPr>
+          <a:xfrm>
+            <a:off x="2396446" y="1005840"/>
+            <a:ext cx="7398802" cy="5394960"/>
+          </a:xfrm>
+          <a:prstGeom prst="rect">
+            <a:avLst/>
+          </a:prstGeom>
+        </p:spPr>
+      </p:pic>
+    </p:spTree>
+  </p:cSld>
+  <p:clrMapOvr>
+    <a:masterClrMapping/>
+  </p:clrMapOvr>
+</p:sld>
+</file>
+
+<file path=ppt/slides/slide14.xml><?xml version="1.0" encoding="utf-8"?>
+<p:sld xmlns:a="http://schemas.openxmlformats.org/drawingml/2006/main" xmlns:p="http://schemas.openxmlformats.org/presentationml/2006/main" xmlns:r="http://schemas.openxmlformats.org/officeDocument/2006/relationships">
+  <p:cSld>
+    <p:bg>
+      <p:bgPr>
+        <a:solidFill>
+          <a:srgbClr val="0B1E2D"/>
+        </a:solidFill>
+        <a:effectLst/>
+      </p:bgPr>
+    </p:bg>
+    <p:spTree>
+      <p:nvGrpSpPr>
+        <p:cNvPr id="1" name=""/>
+        <p:cNvGrpSpPr/>
+        <p:nvPr/>
+      </p:nvGrpSpPr>
+      <p:grpSpPr/>
+      <p:sp>
+        <p:nvSpPr>
+          <p:cNvPr id="2" name="TextBox 1"/>
+          <p:cNvSpPr txBox="1"/>
+          <p:nvPr/>
+        </p:nvSpPr>
+        <p:spPr>
+          <a:xfrm>
+            <a:off x="548640" y="228600"/>
+            <a:ext cx="10972800" cy="548640"/>
+          </a:xfrm>
+          <a:prstGeom prst="rect">
+            <a:avLst/>
+          </a:prstGeom>
+          <a:noFill/>
+        </p:spPr>
+        <p:txBody>
+          <a:bodyPr wrap="square" lIns="0" rIns="0">
+            <a:spAutoFit/>
+          </a:bodyPr>
+          <a:lstStyle/>
+          <a:p>
+            <a:pPr>
+              <a:spcAft>
+                <a:spcPts val="1000"/>
+              </a:spcAft>
+              <a:defRPr sz="2600" b="1">
+                <a:solidFill>
+                  <a:srgbClr val="F3F7FA"/>
+                </a:solidFill>
+                <a:latin typeface="Aptos"/>
+              </a:defRPr>
+            </a:pPr>
+            <a:r>
+              <a:t>Evidencia B · Resumen de exportación real de SonarQube</a:t>
+            </a:r>
+          </a:p>
+        </p:txBody>
+      </p:sp>
+      <p:pic>
+        <p:nvPicPr>
+          <p:cNvPr id="3" name="Picture 2" descr="sonarqube_metricas_exportadas.png"/>
+          <p:cNvPicPr>
+            <a:picLocks noChangeAspect="1"/>
+          </p:cNvPicPr>
+          <p:nvPr/>
+        </p:nvPicPr>
+        <p:blipFill>
+          <a:blip r:embed="rId2"/>
+          <a:stretch>
+            <a:fillRect/>
+          </a:stretch>
+        </p:blipFill>
+        <p:spPr>
+          <a:xfrm>
+            <a:off x="2049627" y="1005840"/>
+            <a:ext cx="8092440" cy="5394960"/>
+          </a:xfrm>
+          <a:prstGeom prst="rect">
+            <a:avLst/>
+          </a:prstGeom>
+        </p:spPr>
+      </p:pic>
+    </p:spTree>
+  </p:cSld>
+  <p:clrMapOvr>
+    <a:masterClrMapping/>
+  </p:clrMapOvr>
+</p:sld>
+</file>
+
 <file path=ppt/slides/slide2.xml><?xml version="1.0" encoding="utf-8"?>
 <p:sld xmlns:a="http://schemas.openxmlformats.org/drawingml/2006/main" xmlns:p="http://schemas.openxmlformats.org/presentationml/2006/main" xmlns:r="http://schemas.openxmlformats.org/officeDocument/2006/relationships">
   <p:cSld>
@@ -11458,7 +11778,7 @@
               </a:defRPr>
             </a:pPr>
             <a:r>
-              <a:t>Bugs: N/D · Vulnerabilities: N/D · Hotspots: N/D · Smells: N/D</a:t>
+              <a:t>Bugs: 1 · Vulnerabilities: 0 · Hotspots: 3 · Smells: 72</a:t>
             </a:r>
           </a:p>
         </p:txBody>
@@ -11540,7 +11860,7 @@
               </a:defRPr>
             </a:pPr>
             <a:r>
-              <a:t>Quality Gate: PENDIENTE · Coverage: N/D%</a:t>
+              <a:t>Quality Gate: OK · Coverage: 0.0%</a:t>
             </a:r>
           </a:p>
         </p:txBody>

</xml_diff>